<commit_message>
Refine hackathon pitch deck
</commit_message>
<xml_diff>
--- a/docs/bountix-pitch-deck.pptx
+++ b/docs/bountix-pitch-deck.pptx
@@ -177,7 +177,7 @@
                   <a:srgbClr val="4B5563"/>
                 </a:solidFill>
               </a:rPr>
-              <a:t>Trusted Task Marketplace Powered by Stellar Escrow</a:t>
+              <a:t>Escrow-powered task marketplace for everyday work in SEA</a:t>
             </a:r>
           </a:p>
         </p:txBody>
@@ -211,33 +211,33 @@
                   <a:srgbClr val="172033"/>
                 </a:solidFill>
               </a:rPr>
-              <a:t>A consumer app for everyday tasks in SEA</a:t>
-            </a:r>
-          </a:p>
-          <a:p>
-            <a:pPr marL="285750" indent="-171450">
-              <a:buChar char="•"/>
-            </a:pPr>
-            <a:r>
-              <a:rPr lang="en-US" sz="2050">
-                <a:solidFill>
-                  <a:srgbClr val="172033"/>
-                </a:solidFill>
-              </a:rPr>
-              <a:t>Built for freelance tasks, errands, local services, micro-jobs, and personal shopping assistance</a:t>
-            </a:r>
-          </a:p>
-          <a:p>
-            <a:pPr marL="285750" indent="-171450">
-              <a:buChar char="•"/>
-            </a:pPr>
-            <a:r>
-              <a:rPr lang="en-US" sz="2050">
-                <a:solidFill>
-                  <a:srgbClr val="172033"/>
-                </a:solidFill>
-              </a:rPr>
-              <a:t>Uses USDC escrow on Stellar to make trust programmable</a:t>
+              <a:t>Post tasks, accept taskers, fund escrow, and release payouts in one flow</a:t>
+            </a:r>
+          </a:p>
+          <a:p>
+            <a:pPr marL="285750" indent="-171450">
+              <a:buChar char="•"/>
+            </a:pPr>
+            <a:r>
+              <a:rPr lang="en-US" sz="2050">
+                <a:solidFill>
+                  <a:srgbClr val="172033"/>
+                </a:solidFill>
+              </a:rPr>
+              <a:t>Built for freelance tasks, micro-jobs, errands, local services, and personal shopping assistance</a:t>
+            </a:r>
+          </a:p>
+          <a:p>
+            <a:pPr marL="285750" indent="-171450">
+              <a:buChar char="•"/>
+            </a:pPr>
+            <a:r>
+              <a:rPr lang="en-US" sz="2050">
+                <a:solidFill>
+                  <a:srgbClr val="172033"/>
+                </a:solidFill>
+              </a:rPr>
+              <a:t>Powered by Stellar USDC escrow to make informal work safer and more transparent</a:t>
             </a:r>
           </a:p>
         </p:txBody>
@@ -404,7 +404,7 @@
                   <a:srgbClr val="111827"/>
                 </a:solidFill>
               </a:rPr>
-              <a:t>Roadmap</a:t>
+              <a:t>Next Steps</a:t>
             </a:r>
           </a:p>
         </p:txBody>
@@ -438,59 +438,59 @@
                   <a:srgbClr val="172033"/>
                 </a:solidFill>
               </a:rPr>
-              <a:t>Dispute resolution and evidence review workflow</a:t>
-            </a:r>
-          </a:p>
-          <a:p>
-            <a:pPr marL="285750" indent="-171450">
-              <a:buChar char="•"/>
-            </a:pPr>
-            <a:r>
-              <a:rPr lang="en-US" sz="2050">
-                <a:solidFill>
-                  <a:srgbClr val="172033"/>
-                </a:solidFill>
-              </a:rPr>
-              <a:t>Reputation, tasker profiles, and completion history</a:t>
-            </a:r>
-          </a:p>
-          <a:p>
-            <a:pPr marL="285750" indent="-171450">
-              <a:buChar char="•"/>
-            </a:pPr>
-            <a:r>
-              <a:rPr lang="en-US" sz="2050">
-                <a:solidFill>
-                  <a:srgbClr val="172033"/>
-                </a:solidFill>
-              </a:rPr>
-              <a:t>Mobile-first experience for field tasks and local services</a:t>
-            </a:r>
-          </a:p>
-          <a:p>
-            <a:pPr marL="285750" indent="-171450">
-              <a:buChar char="•"/>
-            </a:pPr>
-            <a:r>
-              <a:rPr lang="en-US" sz="2050">
-                <a:solidFill>
-                  <a:srgbClr val="172033"/>
-                </a:solidFill>
-              </a:rPr>
-              <a:t>More task categories and community moderation tools</a:t>
-            </a:r>
-          </a:p>
-          <a:p>
-            <a:pPr marL="285750" indent="-171450">
-              <a:buChar char="•"/>
-            </a:pPr>
-            <a:r>
-              <a:rPr lang="en-US" sz="2050">
-                <a:solidFill>
-                  <a:srgbClr val="172033"/>
-                </a:solidFill>
-              </a:rPr>
-              <a:t>Production hardening for compliance, security, and scale</a:t>
+              <a:t>Add dispute resolution and evidence review</a:t>
+            </a:r>
+          </a:p>
+          <a:p>
+            <a:pPr marL="285750" indent="-171450">
+              <a:buChar char="•"/>
+            </a:pPr>
+            <a:r>
+              <a:rPr lang="en-US" sz="2050">
+                <a:solidFill>
+                  <a:srgbClr val="172033"/>
+                </a:solidFill>
+              </a:rPr>
+              <a:t>Build reputation, tasker profiles, and completion history</a:t>
+            </a:r>
+          </a:p>
+          <a:p>
+            <a:pPr marL="285750" indent="-171450">
+              <a:buChar char="•"/>
+            </a:pPr>
+            <a:r>
+              <a:rPr lang="en-US" sz="2050">
+                <a:solidFill>
+                  <a:srgbClr val="172033"/>
+                </a:solidFill>
+              </a:rPr>
+              <a:t>Improve mobile-first UX for field tasks and local services</a:t>
+            </a:r>
+          </a:p>
+          <a:p>
+            <a:pPr marL="285750" indent="-171450">
+              <a:buChar char="•"/>
+            </a:pPr>
+            <a:r>
+              <a:rPr lang="en-US" sz="2050">
+                <a:solidFill>
+                  <a:srgbClr val="172033"/>
+                </a:solidFill>
+              </a:rPr>
+              <a:t>Expand moderation, task categories, and payout reporting</a:t>
+            </a:r>
+          </a:p>
+          <a:p>
+            <a:pPr marL="285750" indent="-171450">
+              <a:buChar char="•"/>
+            </a:pPr>
+            <a:r>
+              <a:rPr lang="en-US" sz="2050">
+                <a:solidFill>
+                  <a:srgbClr val="172033"/>
+                </a:solidFill>
+              </a:rPr>
+              <a:t>Harden compliance, security, and production operations</a:t>
             </a:r>
           </a:p>
         </p:txBody>
@@ -657,7 +657,7 @@
                   <a:srgbClr val="111827"/>
                 </a:solidFill>
               </a:rPr>
-              <a:t>Problem</a:t>
+              <a:t>The Problem</a:t>
             </a:r>
           </a:p>
         </p:txBody>
@@ -691,46 +691,46 @@
                   <a:srgbClr val="172033"/>
                 </a:solidFill>
               </a:rPr>
-              <a:t>Many everyday tasks still happen through chat groups, social media, and personal networks</a:t>
-            </a:r>
-          </a:p>
-          <a:p>
-            <a:pPr marL="285750" indent="-171450">
-              <a:buChar char="•"/>
-            </a:pPr>
-            <a:r>
-              <a:rPr lang="en-US" sz="2050">
-                <a:solidFill>
-                  <a:srgbClr val="172033"/>
-                </a:solidFill>
-              </a:rPr>
-              <a:t>Requesters worry that work may not be completed after payment</a:t>
-            </a:r>
-          </a:p>
-          <a:p>
-            <a:pPr marL="285750" indent="-171450">
-              <a:buChar char="•"/>
-            </a:pPr>
-            <a:r>
-              <a:rPr lang="en-US" sz="2050">
-                <a:solidFill>
-                  <a:srgbClr val="172033"/>
-                </a:solidFill>
-              </a:rPr>
-              <a:t>Taskers worry about delayed or unpaid work after completing a task</a:t>
-            </a:r>
-          </a:p>
-          <a:p>
-            <a:pPr marL="285750" indent="-171450">
-              <a:buChar char="•"/>
-            </a:pPr>
-            <a:r>
-              <a:rPr lang="en-US" sz="2050">
-                <a:solidFill>
-                  <a:srgbClr val="172033"/>
-                </a:solidFill>
-              </a:rPr>
-              <a:t>Existing platforms are often too narrow, expensive, or not designed for flexible real-world tasks</a:t>
+              <a:t>Everyday task work in SEA often happens through chat groups and social media</a:t>
+            </a:r>
+          </a:p>
+          <a:p>
+            <a:pPr marL="285750" indent="-171450">
+              <a:buChar char="•"/>
+            </a:pPr>
+            <a:r>
+              <a:rPr lang="en-US" sz="2050">
+                <a:solidFill>
+                  <a:srgbClr val="172033"/>
+                </a:solidFill>
+              </a:rPr>
+              <a:t>Requesters and taskers rely on informal trust instead of clear payment protection</a:t>
+            </a:r>
+          </a:p>
+          <a:p>
+            <a:pPr marL="285750" indent="-171450">
+              <a:buChar char="•"/>
+            </a:pPr>
+            <a:r>
+              <a:rPr lang="en-US" sz="2050">
+                <a:solidFill>
+                  <a:srgbClr val="172033"/>
+                </a:solidFill>
+              </a:rPr>
+              <a:t>Taskers risk delayed or unpaid work, while requesters risk paying before completion</a:t>
+            </a:r>
+          </a:p>
+          <a:p>
+            <a:pPr marL="285750" indent="-171450">
+              <a:buChar char="•"/>
+            </a:pPr>
+            <a:r>
+              <a:rPr lang="en-US" sz="2050">
+                <a:solidFill>
+                  <a:srgbClr val="172033"/>
+                </a:solidFill>
+              </a:rPr>
+              <a:t>Most platforms are too rigid for flexible real-world tasks like errands or personal shopping</a:t>
             </a:r>
           </a:p>
         </p:txBody>
@@ -897,7 +897,7 @@
                   <a:srgbClr val="111827"/>
                 </a:solidFill>
               </a:rPr>
-              <a:t>Solution</a:t>
+              <a:t>Our Solution</a:t>
             </a:r>
           </a:p>
         </p:txBody>
@@ -931,46 +931,46 @@
                   <a:srgbClr val="172033"/>
                 </a:solidFill>
               </a:rPr>
-              <a:t>Bountix turns informal task requests into secure, trackable transactions</a:t>
-            </a:r>
-          </a:p>
-          <a:p>
-            <a:pPr marL="285750" indent="-171450">
-              <a:buChar char="•"/>
-            </a:pPr>
-            <a:r>
-              <a:rPr lang="en-US" sz="2050">
-                <a:solidFill>
-                  <a:srgbClr val="172033"/>
-                </a:solidFill>
-              </a:rPr>
-              <a:t>Requesters post tasks, review applicants, choose taskers, and fund escrow</a:t>
-            </a:r>
-          </a:p>
-          <a:p>
-            <a:pPr marL="285750" indent="-171450">
-              <a:buChar char="•"/>
-            </a:pPr>
-            <a:r>
-              <a:rPr lang="en-US" sz="2050">
-                <a:solidFill>
-                  <a:srgbClr val="172033"/>
-                </a:solidFill>
-              </a:rPr>
-              <a:t>Taskers complete work and communicate through participant-only chat</a:t>
-            </a:r>
-          </a:p>
-          <a:p>
-            <a:pPr marL="285750" indent="-171450">
-              <a:buChar char="•"/>
-            </a:pPr>
-            <a:r>
-              <a:rPr lang="en-US" sz="2050">
-                <a:solidFill>
-                  <a:srgbClr val="172033"/>
-                </a:solidFill>
-              </a:rPr>
-              <a:t>Funds are released after approval by the requester or admin</a:t>
+              <a:t>Bountix turns informal task requests into secure, trackable task transactions</a:t>
+            </a:r>
+          </a:p>
+          <a:p>
+            <a:pPr marL="285750" indent="-171450">
+              <a:buChar char="•"/>
+            </a:pPr>
+            <a:r>
+              <a:rPr lang="en-US" sz="2050">
+                <a:solidFill>
+                  <a:srgbClr val="172033"/>
+                </a:solidFill>
+              </a:rPr>
+              <a:t>A requester creates a task, selects a tasker, and locks payment before work starts</a:t>
+            </a:r>
+          </a:p>
+          <a:p>
+            <a:pPr marL="285750" indent="-171450">
+              <a:buChar char="•"/>
+            </a:pPr>
+            <a:r>
+              <a:rPr lang="en-US" sz="2050">
+                <a:solidFill>
+                  <a:srgbClr val="172033"/>
+                </a:solidFill>
+              </a:rPr>
+              <a:t>Taskers complete work with participant-only chat, notifications, and task status tracking</a:t>
+            </a:r>
+          </a:p>
+          <a:p>
+            <a:pPr marL="285750" indent="-171450">
+              <a:buChar char="•"/>
+            </a:pPr>
+            <a:r>
+              <a:rPr lang="en-US" sz="2050">
+                <a:solidFill>
+                  <a:srgbClr val="172033"/>
+                </a:solidFill>
+              </a:rPr>
+              <a:t>Escrow is released only after completion is approved by the requester or admin</a:t>
             </a:r>
           </a:p>
         </p:txBody>
@@ -1137,7 +1137,7 @@
                   <a:srgbClr val="111827"/>
                 </a:solidFill>
               </a:rPr>
-              <a:t>How It Works</a:t>
+              <a:t>Product Flow</a:t>
             </a:r>
           </a:p>
         </p:txBody>
@@ -1171,59 +1171,59 @@
                   <a:srgbClr val="172033"/>
                 </a:solidFill>
               </a:rPr>
-              <a:t>1. Requester creates a task with reward, location/category, and requirements</a:t>
-            </a:r>
-          </a:p>
-          <a:p>
-            <a:pPr marL="285750" indent="-171450">
-              <a:buChar char="•"/>
-            </a:pPr>
-            <a:r>
-              <a:rPr lang="en-US" sz="2050">
-                <a:solidFill>
-                  <a:srgbClr val="172033"/>
-                </a:solidFill>
-              </a:rPr>
-              <a:t>2. Taskers apply and discuss details in task chat after acceptance</a:t>
-            </a:r>
-          </a:p>
-          <a:p>
-            <a:pPr marL="285750" indent="-171450">
-              <a:buChar char="•"/>
-            </a:pPr>
-            <a:r>
-              <a:rPr lang="en-US" sz="2050">
-                <a:solidFill>
-                  <a:srgbClr val="172033"/>
-                </a:solidFill>
-              </a:rPr>
-              <a:t>3. Requester funds the task escrow using USDC on Stellar</a:t>
-            </a:r>
-          </a:p>
-          <a:p>
-            <a:pPr marL="285750" indent="-171450">
-              <a:buChar char="•"/>
-            </a:pPr>
-            <a:r>
-              <a:rPr lang="en-US" sz="2050">
-                <a:solidFill>
-                  <a:srgbClr val="172033"/>
-                </a:solidFill>
-              </a:rPr>
-              <a:t>4. Tasker completes the work and submits proof or updates</a:t>
-            </a:r>
-          </a:p>
-          <a:p>
-            <a:pPr marL="285750" indent="-171450">
-              <a:buChar char="•"/>
-            </a:pPr>
-            <a:r>
-              <a:rPr lang="en-US" sz="2050">
-                <a:solidFill>
-                  <a:srgbClr val="172033"/>
-                </a:solidFill>
-              </a:rPr>
-              <a:t>5. Escrow is released to the tasker after approval</a:t>
+              <a:t>Create a task with reward, category, deadline, and requirements</a:t>
+            </a:r>
+          </a:p>
+          <a:p>
+            <a:pPr marL="285750" indent="-171450">
+              <a:buChar char="•"/>
+            </a:pPr>
+            <a:r>
+              <a:rPr lang="en-US" sz="2050">
+                <a:solidFill>
+                  <a:srgbClr val="172033"/>
+                </a:solidFill>
+              </a:rPr>
+              <a:t>Taskers apply, requester reviews applicants, and one tasker is accepted</a:t>
+            </a:r>
+          </a:p>
+          <a:p>
+            <a:pPr marL="285750" indent="-171450">
+              <a:buChar char="•"/>
+            </a:pPr>
+            <a:r>
+              <a:rPr lang="en-US" sz="2050">
+                <a:solidFill>
+                  <a:srgbClr val="172033"/>
+                </a:solidFill>
+              </a:rPr>
+              <a:t>Requester funds the task escrow using USDC on Stellar</a:t>
+            </a:r>
+          </a:p>
+          <a:p>
+            <a:pPr marL="285750" indent="-171450">
+              <a:buChar char="•"/>
+            </a:pPr>
+            <a:r>
+              <a:rPr lang="en-US" sz="2050">
+                <a:solidFill>
+                  <a:srgbClr val="172033"/>
+                </a:solidFill>
+              </a:rPr>
+              <a:t>Accepted participants coordinate in task chat and complete the work</a:t>
+            </a:r>
+          </a:p>
+          <a:p>
+            <a:pPr marL="285750" indent="-171450">
+              <a:buChar char="•"/>
+            </a:pPr>
+            <a:r>
+              <a:rPr lang="en-US" sz="2050">
+                <a:solidFill>
+                  <a:srgbClr val="172033"/>
+                </a:solidFill>
+              </a:rPr>
+              <a:t>Requester or admin releases escrow and the tasker sees the payout in wallet history</a:t>
             </a:r>
           </a:p>
         </p:txBody>
@@ -1390,7 +1390,7 @@
                   <a:srgbClr val="111827"/>
                 </a:solidFill>
               </a:rPr>
-              <a:t>Stellar Integration</a:t>
+              <a:t>Why Stellar</a:t>
             </a:r>
           </a:p>
         </p:txBody>
@@ -1424,59 +1424,59 @@
                   <a:srgbClr val="172033"/>
                 </a:solidFill>
               </a:rPr>
-              <a:t>USDC escrow is funded before work starts</a:t>
-            </a:r>
-          </a:p>
-          <a:p>
-            <a:pPr marL="285750" indent="-171450">
-              <a:buChar char="•"/>
-            </a:pPr>
-            <a:r>
-              <a:rPr lang="en-US" sz="2050">
-                <a:solidFill>
-                  <a:srgbClr val="172033"/>
-                </a:solidFill>
-              </a:rPr>
-              <a:t>On-chain release flow records payout activity transparently</a:t>
-            </a:r>
-          </a:p>
-          <a:p>
-            <a:pPr marL="285750" indent="-171450">
-              <a:buChar char="•"/>
-            </a:pPr>
-            <a:r>
-              <a:rPr lang="en-US" sz="2050">
-                <a:solidFill>
-                  <a:srgbClr val="172033"/>
-                </a:solidFill>
-              </a:rPr>
-              <a:t>Automatic wallet creation reduces onboarding friction for new users</a:t>
-            </a:r>
-          </a:p>
-          <a:p>
-            <a:pPr marL="285750" indent="-171450">
-              <a:buChar char="•"/>
-            </a:pPr>
-            <a:r>
-              <a:rPr lang="en-US" sz="2050">
-                <a:solidFill>
-                  <a:srgbClr val="172033"/>
-                </a:solidFill>
-              </a:rPr>
-              <a:t>USDC payout readiness handles Stellar trustline requirements</a:t>
-            </a:r>
-          </a:p>
-          <a:p>
-            <a:pPr marL="285750" indent="-171450">
-              <a:buChar char="•"/>
-            </a:pPr>
-            <a:r>
-              <a:rPr lang="en-US" sz="2050">
-                <a:solidFill>
-                  <a:srgbClr val="172033"/>
-                </a:solidFill>
-              </a:rPr>
-              <a:t>Wallet dashboard shows recent transaction activity</a:t>
+              <a:t>Fast and low-cost USDC settlement fits small task payments</a:t>
+            </a:r>
+          </a:p>
+          <a:p>
+            <a:pPr marL="285750" indent="-171450">
+              <a:buChar char="•"/>
+            </a:pPr>
+            <a:r>
+              <a:rPr lang="en-US" sz="2050">
+                <a:solidFill>
+                  <a:srgbClr val="172033"/>
+                </a:solidFill>
+              </a:rPr>
+              <a:t>Escrow makes payment trust programmable instead of verbal</a:t>
+            </a:r>
+          </a:p>
+          <a:p>
+            <a:pPr marL="285750" indent="-171450">
+              <a:buChar char="•"/>
+            </a:pPr>
+            <a:r>
+              <a:rPr lang="en-US" sz="2050">
+                <a:solidFill>
+                  <a:srgbClr val="172033"/>
+                </a:solidFill>
+              </a:rPr>
+              <a:t>On-chain release records improve transparency for both sides</a:t>
+            </a:r>
+          </a:p>
+          <a:p>
+            <a:pPr marL="285750" indent="-171450">
+              <a:buChar char="•"/>
+            </a:pPr>
+            <a:r>
+              <a:rPr lang="en-US" sz="2050">
+                <a:solidFill>
+                  <a:srgbClr val="172033"/>
+                </a:solidFill>
+              </a:rPr>
+              <a:t>Wallet onboarding and payout readiness hide Stellar complexity from everyday users</a:t>
+            </a:r>
+          </a:p>
+          <a:p>
+            <a:pPr marL="285750" indent="-171450">
+              <a:buChar char="•"/>
+            </a:pPr>
+            <a:r>
+              <a:rPr lang="en-US" sz="2050">
+                <a:solidFill>
+                  <a:srgbClr val="172033"/>
+                </a:solidFill>
+              </a:rPr>
+              <a:t>Stellar creates a practical payment rail for real-world consumer applications</a:t>
             </a:r>
           </a:p>
         </p:txBody>
@@ -1643,7 +1643,7 @@
                   <a:srgbClr val="111827"/>
                 </a:solidFill>
               </a:rPr>
-              <a:t>Product Features</a:t>
+              <a:t>Built Prototype</a:t>
             </a:r>
           </a:p>
         </p:txBody>
@@ -1690,46 +1690,46 @@
                   <a:srgbClr val="172033"/>
                 </a:solidFill>
               </a:rPr>
-              <a:t>Participant-only Tencent Chat integration for accepted task conversations</a:t>
-            </a:r>
-          </a:p>
-          <a:p>
-            <a:pPr marL="285750" indent="-171450">
-              <a:buChar char="•"/>
-            </a:pPr>
-            <a:r>
-              <a:rPr lang="en-US" sz="2050">
-                <a:solidFill>
-                  <a:srgbClr val="172033"/>
-                </a:solidFill>
-              </a:rPr>
-              <a:t>Notifications for applications, task updates, escrow activity, and payouts</a:t>
-            </a:r>
-          </a:p>
-          <a:p>
-            <a:pPr marL="285750" indent="-171450">
-              <a:buChar char="•"/>
-            </a:pPr>
-            <a:r>
-              <a:rPr lang="en-US" sz="2050">
-                <a:solidFill>
-                  <a:srgbClr val="172033"/>
-                </a:solidFill>
-              </a:rPr>
-              <a:t>Admin moderation to remove unsafe or prohibited tasks with a reason</a:t>
-            </a:r>
-          </a:p>
-          <a:p>
-            <a:pPr marL="285750" indent="-171450">
-              <a:buChar char="•"/>
-            </a:pPr>
-            <a:r>
-              <a:rPr lang="en-US" sz="2050">
-                <a:solidFill>
-                  <a:srgbClr val="172033"/>
-                </a:solidFill>
-              </a:rPr>
-              <a:t>Wallet onboarding, recovery, escrow funding, release, and transaction history</a:t>
+              <a:t>Stellar wallet onboarding, USDC payout readiness, escrow funding, and release</a:t>
+            </a:r>
+          </a:p>
+          <a:p>
+            <a:pPr marL="285750" indent="-171450">
+              <a:buChar char="•"/>
+            </a:pPr>
+            <a:r>
+              <a:rPr lang="en-US" sz="2050">
+                <a:solidFill>
+                  <a:srgbClr val="172033"/>
+                </a:solidFill>
+              </a:rPr>
+              <a:t>Participant-only Tencent Chat for accepted task conversations</a:t>
+            </a:r>
+          </a:p>
+          <a:p>
+            <a:pPr marL="285750" indent="-171450">
+              <a:buChar char="•"/>
+            </a:pPr>
+            <a:r>
+              <a:rPr lang="en-US" sz="2050">
+                <a:solidFill>
+                  <a:srgbClr val="172033"/>
+                </a:solidFill>
+              </a:rPr>
+              <a:t>Notifications for applications, task updates, escrow events, and payouts</a:t>
+            </a:r>
+          </a:p>
+          <a:p>
+            <a:pPr marL="285750" indent="-171450">
+              <a:buChar char="•"/>
+            </a:pPr>
+            <a:r>
+              <a:rPr lang="en-US" sz="2050">
+                <a:solidFill>
+                  <a:srgbClr val="172033"/>
+                </a:solidFill>
+              </a:rPr>
+              <a:t>Admin moderation with task removal reason and wallet transaction history</a:t>
             </a:r>
           </a:p>
         </p:txBody>
@@ -1930,46 +1930,46 @@
                   <a:srgbClr val="172033"/>
                 </a:solidFill>
               </a:rPr>
-              <a:t>Students, freelancers, creators, small business owners, and community organizers</a:t>
-            </a:r>
-          </a:p>
-          <a:p>
-            <a:pPr marL="285750" indent="-171450">
-              <a:buChar char="•"/>
-            </a:pPr>
-            <a:r>
-              <a:rPr lang="en-US" sz="2050">
-                <a:solidFill>
-                  <a:srgbClr val="172033"/>
-                </a:solidFill>
-              </a:rPr>
-              <a:t>People who need errands, local services, personal shopping assistance, or micro-work</a:t>
-            </a:r>
-          </a:p>
-          <a:p>
-            <a:pPr marL="285750" indent="-171450">
-              <a:buChar char="•"/>
-            </a:pPr>
-            <a:r>
-              <a:rPr lang="en-US" sz="2050">
-                <a:solidFill>
-                  <a:srgbClr val="172033"/>
-                </a:solidFill>
-              </a:rPr>
-              <a:t>Taskers who want flexible short-term income with better payment protection</a:t>
-            </a:r>
-          </a:p>
-          <a:p>
-            <a:pPr marL="285750" indent="-171450">
-              <a:buChar char="•"/>
-            </a:pPr>
-            <a:r>
-              <a:rPr lang="en-US" sz="2050">
-                <a:solidFill>
-                  <a:srgbClr val="172033"/>
-                </a:solidFill>
-              </a:rPr>
-              <a:t>SEA communities where informal work already happens but trust is still manual</a:t>
+              <a:t>Requesters who need flexible help with online or real-world tasks</a:t>
+            </a:r>
+          </a:p>
+          <a:p>
+            <a:pPr marL="285750" indent="-171450">
+              <a:buChar char="•"/>
+            </a:pPr>
+            <a:r>
+              <a:rPr lang="en-US" sz="2050">
+                <a:solidFill>
+                  <a:srgbClr val="172033"/>
+                </a:solidFill>
+              </a:rPr>
+              <a:t>Taskers who want short-term income with clearer payment protection</a:t>
+            </a:r>
+          </a:p>
+          <a:p>
+            <a:pPr marL="285750" indent="-171450">
+              <a:buChar char="•"/>
+            </a:pPr>
+            <a:r>
+              <a:rPr lang="en-US" sz="2050">
+                <a:solidFill>
+                  <a:srgbClr val="172033"/>
+                </a:solidFill>
+              </a:rPr>
+              <a:t>Students, freelancers, creators, small businesses, and community organizers</a:t>
+            </a:r>
+          </a:p>
+          <a:p>
+            <a:pPr marL="285750" indent="-171450">
+              <a:buChar char="•"/>
+            </a:pPr>
+            <a:r>
+              <a:rPr lang="en-US" sz="2050">
+                <a:solidFill>
+                  <a:srgbClr val="172033"/>
+                </a:solidFill>
+              </a:rPr>
+              <a:t>SEA communities where informal work already exists but payment trust is still manual</a:t>
             </a:r>
           </a:p>
         </p:txBody>
@@ -2136,7 +2136,7 @@
                   <a:srgbClr val="111827"/>
                 </a:solidFill>
               </a:rPr>
-              <a:t>Demo Flow</a:t>
+              <a:t>Demo Highlights</a:t>
             </a:r>
           </a:p>
         </p:txBody>
@@ -2170,59 +2170,59 @@
                   <a:srgbClr val="172033"/>
                 </a:solidFill>
               </a:rPr>
-              <a:t>Sign in and automatically create a Stellar-ready wallet</a:t>
-            </a:r>
-          </a:p>
-          <a:p>
-            <a:pPr marL="285750" indent="-171450">
-              <a:buChar char="•"/>
-            </a:pPr>
-            <a:r>
-              <a:rPr lang="en-US" sz="2050">
-                <a:solidFill>
-                  <a:srgbClr val="172033"/>
-                </a:solidFill>
-              </a:rPr>
-              <a:t>Create a task and receive tasker applications</a:t>
-            </a:r>
-          </a:p>
-          <a:p>
-            <a:pPr marL="285750" indent="-171450">
-              <a:buChar char="•"/>
-            </a:pPr>
-            <a:r>
-              <a:rPr lang="en-US" sz="2050">
-                <a:solidFill>
-                  <a:srgbClr val="172033"/>
-                </a:solidFill>
-              </a:rPr>
-              <a:t>Accept an applicant and use participant-only chat</a:t>
-            </a:r>
-          </a:p>
-          <a:p>
-            <a:pPr marL="285750" indent="-171450">
-              <a:buChar char="•"/>
-            </a:pPr>
-            <a:r>
-              <a:rPr lang="en-US" sz="2050">
-                <a:solidFill>
-                  <a:srgbClr val="172033"/>
-                </a:solidFill>
-              </a:rPr>
-              <a:t>Fund escrow with USDC on Stellar</a:t>
-            </a:r>
-          </a:p>
-          <a:p>
-            <a:pPr marL="285750" indent="-171450">
-              <a:buChar char="•"/>
-            </a:pPr>
-            <a:r>
-              <a:rPr lang="en-US" sz="2050">
-                <a:solidFill>
-                  <a:srgbClr val="172033"/>
-                </a:solidFill>
-              </a:rPr>
-              <a:t>Release escrow and show tasker wallet transaction history</a:t>
+              <a:t>Google login creates a wallet automatically for new users</a:t>
+            </a:r>
+          </a:p>
+          <a:p>
+            <a:pPr marL="285750" indent="-171450">
+              <a:buChar char="•"/>
+            </a:pPr>
+            <a:r>
+              <a:rPr lang="en-US" sz="2050">
+                <a:solidFill>
+                  <a:srgbClr val="172033"/>
+                </a:solidFill>
+              </a:rPr>
+              <a:t>Requester creates a task, receives applications, and accepts a tasker</a:t>
+            </a:r>
+          </a:p>
+          <a:p>
+            <a:pPr marL="285750" indent="-171450">
+              <a:buChar char="•"/>
+            </a:pPr>
+            <a:r>
+              <a:rPr lang="en-US" sz="2050">
+                <a:solidFill>
+                  <a:srgbClr val="172033"/>
+                </a:solidFill>
+              </a:rPr>
+              <a:t>Accepted participants can use private task chat</a:t>
+            </a:r>
+          </a:p>
+          <a:p>
+            <a:pPr marL="285750" indent="-171450">
+              <a:buChar char="•"/>
+            </a:pPr>
+            <a:r>
+              <a:rPr lang="en-US" sz="2050">
+                <a:solidFill>
+                  <a:srgbClr val="172033"/>
+                </a:solidFill>
+              </a:rPr>
+              <a:t>Requester funds Stellar USDC escrow and admin/requester releases payout</a:t>
+            </a:r>
+          </a:p>
+          <a:p>
+            <a:pPr marL="285750" indent="-171450">
+              <a:buChar char="•"/>
+            </a:pPr>
+            <a:r>
+              <a:rPr lang="en-US" sz="2050">
+                <a:solidFill>
+                  <a:srgbClr val="172033"/>
+                </a:solidFill>
+              </a:rPr>
+              <a:t>Tasker wallet shows recent transaction history after release</a:t>
             </a:r>
           </a:p>
         </p:txBody>
@@ -2389,7 +2389,7 @@
                   <a:srgbClr val="111827"/>
                 </a:solidFill>
               </a:rPr>
-              <a:t>Impact</a:t>
+              <a:t>Impact &amp; Market Fit</a:t>
             </a:r>
           </a:p>
         </p:txBody>
@@ -2423,46 +2423,46 @@
                   <a:srgbClr val="172033"/>
                 </a:solidFill>
               </a:rPr>
-              <a:t>Makes informal work safer by locking payment before the task starts</a:t>
-            </a:r>
-          </a:p>
-          <a:p>
-            <a:pPr marL="285750" indent="-171450">
-              <a:buChar char="•"/>
-            </a:pPr>
-            <a:r>
-              <a:rPr lang="en-US" sz="2050">
-                <a:solidFill>
-                  <a:srgbClr val="172033"/>
-                </a:solidFill>
-              </a:rPr>
-              <a:t>Improves transparency for both requesters and taskers</a:t>
-            </a:r>
-          </a:p>
-          <a:p>
-            <a:pPr marL="285750" indent="-171450">
-              <a:buChar char="•"/>
-            </a:pPr>
-            <a:r>
-              <a:rPr lang="en-US" sz="2050">
-                <a:solidFill>
-                  <a:srgbClr val="172033"/>
-                </a:solidFill>
-              </a:rPr>
-              <a:t>Makes Stellar payments usable through a familiar consumer workflow</a:t>
-            </a:r>
-          </a:p>
-          <a:p>
-            <a:pPr marL="285750" indent="-171450">
-              <a:buChar char="•"/>
-            </a:pPr>
-            <a:r>
-              <a:rPr lang="en-US" sz="2050">
-                <a:solidFill>
-                  <a:srgbClr val="172033"/>
-                </a:solidFill>
-              </a:rPr>
-              <a:t>Supports real-world access to digital dollar payouts for flexible work in SEA</a:t>
+              <a:t>Reduces payment risk in informal task work</a:t>
+            </a:r>
+          </a:p>
+          <a:p>
+            <a:pPr marL="285750" indent="-171450">
+              <a:buChar char="•"/>
+            </a:pPr>
+            <a:r>
+              <a:rPr lang="en-US" sz="2050">
+                <a:solidFill>
+                  <a:srgbClr val="172033"/>
+                </a:solidFill>
+              </a:rPr>
+              <a:t>Makes digital dollar payouts accessible through a familiar task marketplace UX</a:t>
+            </a:r>
+          </a:p>
+          <a:p>
+            <a:pPr marL="285750" indent="-171450">
+              <a:buChar char="•"/>
+            </a:pPr>
+            <a:r>
+              <a:rPr lang="en-US" sz="2050">
+                <a:solidFill>
+                  <a:srgbClr val="172033"/>
+                </a:solidFill>
+              </a:rPr>
+              <a:t>Supports broad task categories instead of one narrow service vertical</a:t>
+            </a:r>
+          </a:p>
+          <a:p>
+            <a:pPr marL="285750" indent="-171450">
+              <a:buChar char="•"/>
+            </a:pPr>
+            <a:r>
+              <a:rPr lang="en-US" sz="2050">
+                <a:solidFill>
+                  <a:srgbClr val="172033"/>
+                </a:solidFill>
+              </a:rPr>
+              <a:t>Turns Stellar escrow into a real consumer workflow for SEA users</a:t>
             </a:r>
           </a:p>
         </p:txBody>

</xml_diff>

<commit_message>
Add product screenshots to pitch deck
</commit_message>
<xml_diff>
--- a/docs/bountix-pitch-deck.pptx
+++ b/docs/bountix-pitch-deck.pptx
@@ -177,7 +177,7 @@
                   <a:srgbClr val="4B5563"/>
                 </a:solidFill>
               </a:rPr>
-              <a:t>Escrow-powered task marketplace for everyday work in SEA</a:t>
+              <a:t>Flexible task and service marketplace powered by Stellar escrow</a:t>
             </a:r>
           </a:p>
         </p:txBody>
@@ -190,54 +190,139 @@
         </p:nvSpPr>
         <p:spPr>
           <a:xfrm>
-            <a:off x="780000" y="2180000"/>
-            <a:ext cx="7600000" cy="3600000"/>
-          </a:xfrm>
-          <a:prstGeom prst="rect">
-            <a:avLst/>
-          </a:prstGeom>
-          <a:noFill/>
-        </p:spPr>
-        <p:txBody>
-          <a:bodyPr wrap="square"/>
-          <a:lstStyle/>
-          <a:p>
-            <a:pPr marL="285750" indent="-171450">
-              <a:buChar char="•"/>
-            </a:pPr>
-            <a:r>
-              <a:rPr lang="en-US" sz="2050">
-                <a:solidFill>
-                  <a:srgbClr val="172033"/>
-                </a:solidFill>
-              </a:rPr>
-              <a:t>Post tasks, accept taskers, fund escrow, and release payouts in one flow</a:t>
-            </a:r>
-          </a:p>
-          <a:p>
-            <a:pPr marL="285750" indent="-171450">
-              <a:buChar char="•"/>
-            </a:pPr>
-            <a:r>
-              <a:rPr lang="en-US" sz="2050">
-                <a:solidFill>
-                  <a:srgbClr val="172033"/>
-                </a:solidFill>
-              </a:rPr>
-              <a:t>Built for freelance tasks, micro-jobs, errands, local services, and personal shopping assistance</a:t>
-            </a:r>
-          </a:p>
-          <a:p>
-            <a:pPr marL="285750" indent="-171450">
-              <a:buChar char="•"/>
-            </a:pPr>
-            <a:r>
-              <a:rPr lang="en-US" sz="2050">
-                <a:solidFill>
-                  <a:srgbClr val="172033"/>
-                </a:solidFill>
-              </a:rPr>
-              <a:t>Powered by Stellar USDC escrow to make informal work safer and more transparent</a:t>
+            <a:off x="720000" y="2160000"/>
+            <a:ext cx="4050000" cy="3600000"/>
+          </a:xfrm>
+          <a:prstGeom prst="rect">
+            <a:avLst/>
+          </a:prstGeom>
+          <a:noFill/>
+        </p:spPr>
+        <p:txBody>
+          <a:bodyPr wrap="square"/>
+          <a:lstStyle/>
+          <a:p>
+            <a:pPr marL="285750" indent="-171450">
+              <a:buChar char="•"/>
+            </a:pPr>
+            <a:r>
+              <a:rPr lang="en-US" sz="1720">
+                <a:solidFill>
+                  <a:srgbClr val="172033"/>
+                </a:solidFill>
+              </a:rPr>
+              <a:t>Request help, offer services, coordinate work, and settle payments in one product</a:t>
+            </a:r>
+          </a:p>
+          <a:p>
+            <a:pPr marL="285750" indent="-171450">
+              <a:buChar char="•"/>
+            </a:pPr>
+            <a:r>
+              <a:rPr lang="en-US" sz="1720">
+                <a:solidFill>
+                  <a:srgbClr val="172033"/>
+                </a:solidFill>
+              </a:rPr>
+              <a:t>Built for micro-work, errands, local services, personal shopping assistance, and community tasks</a:t>
+            </a:r>
+          </a:p>
+          <a:p>
+            <a:pPr marL="285750" indent="-171450">
+              <a:buChar char="•"/>
+            </a:pPr>
+            <a:r>
+              <a:rPr lang="en-US" sz="1720">
+                <a:solidFill>
+                  <a:srgbClr val="172033"/>
+                </a:solidFill>
+              </a:rPr>
+              <a:t>Uses Stellar USDC escrow to make flexible work safer, trackable, and easier to trust</a:t>
+            </a:r>
+          </a:p>
+        </p:txBody>
+      </p:sp>
+      <p:sp>
+        <p:nvSpPr>
+          <p:cNvPr id="230" name="Panel 230"/>
+          <p:cNvSpPr/>
+          <p:nvPr/>
+        </p:nvSpPr>
+        <p:spPr>
+          <a:xfrm>
+            <a:off x="6955000" y="1395000"/>
+            <a:ext cx="1510000" cy="3245000"/>
+          </a:xfrm>
+          <a:prstGeom prst="roundRect">
+            <a:avLst/>
+          </a:prstGeom>
+          <a:solidFill>
+            <a:srgbClr val="FFFFFF"/>
+          </a:solidFill>
+          <a:ln>
+            <a:noFill/>
+          </a:ln>
+        </p:spPr>
+      </p:sp>
+      <p:pic>
+        <p:nvPicPr>
+          <p:cNvPr id="30" name="Marketplace Home"/>
+          <p:cNvPicPr>
+            <a:picLocks noChangeAspect="1"/>
+          </p:cNvPicPr>
+          <p:nvPr/>
+        </p:nvPicPr>
+        <p:blipFill>
+          <a:blip r:embed="rId1"/>
+          <a:stretch>
+            <a:fillRect/>
+          </a:stretch>
+        </p:blipFill>
+        <p:spPr>
+          <a:xfrm>
+            <a:off x="7000000" y="1440000"/>
+            <a:ext cx="1420000" cy="3155000"/>
+          </a:xfrm>
+          <a:prstGeom prst="roundRect">
+            <a:avLst/>
+          </a:prstGeom>
+          <a:ln w="12700">
+            <a:solidFill>
+              <a:srgbClr val="E5E7EB"/>
+            </a:solidFill>
+          </a:ln>
+        </p:spPr>
+      </p:pic>
+      <p:sp>
+        <p:nvSpPr>
+          <p:cNvPr id="130" name="Text 130"/>
+          <p:cNvSpPr txBox="1"/>
+          <p:nvPr/>
+        </p:nvSpPr>
+        <p:spPr>
+          <a:xfrm>
+            <a:off x="7000000" y="4685000"/>
+            <a:ext cx="1420000" cy="240000"/>
+          </a:xfrm>
+          <a:prstGeom prst="rect">
+            <a:avLst/>
+          </a:prstGeom>
+          <a:noFill/>
+        </p:spPr>
+        <p:txBody>
+          <a:bodyPr wrap="square"/>
+          <a:lstStyle/>
+          <a:p>
+            <a:pPr>
+              <a:buNone/>
+            </a:pPr>
+            <a:r>
+              <a:rPr lang="en-US" sz="950">
+                <a:solidFill>
+                  <a:srgbClr val="4B5563"/>
+                </a:solidFill>
+              </a:rPr>
+              <a:t>Marketplace Home</a:t>
             </a:r>
           </a:p>
         </p:txBody>
@@ -477,7 +562,7 @@
                   <a:srgbClr val="172033"/>
                 </a:solidFill>
               </a:rPr>
-              <a:t>Expand moderation, task categories, and payout reporting</a:t>
+              <a:t>Expand moderation, task categories, service discovery, and payout reporting</a:t>
             </a:r>
           </a:p>
           <a:p>
@@ -691,7 +776,7 @@
                   <a:srgbClr val="172033"/>
                 </a:solidFill>
               </a:rPr>
-              <a:t>Everyday task work in SEA often happens through chat groups and social media</a:t>
+              <a:t>Everyday work and service requests in SEA often happen through chat groups and social media</a:t>
             </a:r>
           </a:p>
           <a:p>
@@ -730,7 +815,7 @@
                   <a:srgbClr val="172033"/>
                 </a:solidFill>
               </a:rPr>
-              <a:t>Most platforms are too rigid for flexible real-world tasks like errands or personal shopping</a:t>
+              <a:t>Most platforms are too rigid for mixed real-world tasks, local services, and personal shopping</a:t>
             </a:r>
           </a:p>
         </p:txBody>
@@ -910,67 +995,152 @@
         </p:nvSpPr>
         <p:spPr>
           <a:xfrm>
-            <a:off x="780000" y="1840000"/>
-            <a:ext cx="7600000" cy="3600000"/>
-          </a:xfrm>
-          <a:prstGeom prst="rect">
-            <a:avLst/>
-          </a:prstGeom>
-          <a:noFill/>
-        </p:spPr>
-        <p:txBody>
-          <a:bodyPr wrap="square"/>
-          <a:lstStyle/>
-          <a:p>
-            <a:pPr marL="285750" indent="-171450">
-              <a:buChar char="•"/>
-            </a:pPr>
-            <a:r>
-              <a:rPr lang="en-US" sz="2050">
-                <a:solidFill>
-                  <a:srgbClr val="172033"/>
-                </a:solidFill>
-              </a:rPr>
-              <a:t>Bountix turns informal task requests into secure, trackable task transactions</a:t>
-            </a:r>
-          </a:p>
-          <a:p>
-            <a:pPr marL="285750" indent="-171450">
-              <a:buChar char="•"/>
-            </a:pPr>
-            <a:r>
-              <a:rPr lang="en-US" sz="2050">
-                <a:solidFill>
-                  <a:srgbClr val="172033"/>
-                </a:solidFill>
-              </a:rPr>
-              <a:t>A requester creates a task, selects a tasker, and locks payment before work starts</a:t>
-            </a:r>
-          </a:p>
-          <a:p>
-            <a:pPr marL="285750" indent="-171450">
-              <a:buChar char="•"/>
-            </a:pPr>
-            <a:r>
-              <a:rPr lang="en-US" sz="2050">
-                <a:solidFill>
-                  <a:srgbClr val="172033"/>
-                </a:solidFill>
-              </a:rPr>
-              <a:t>Taskers complete work with participant-only chat, notifications, and task status tracking</a:t>
-            </a:r>
-          </a:p>
-          <a:p>
-            <a:pPr marL="285750" indent="-171450">
-              <a:buChar char="•"/>
-            </a:pPr>
-            <a:r>
-              <a:rPr lang="en-US" sz="2050">
+            <a:off x="720000" y="1840000"/>
+            <a:ext cx="4050000" cy="3600000"/>
+          </a:xfrm>
+          <a:prstGeom prst="rect">
+            <a:avLst/>
+          </a:prstGeom>
+          <a:noFill/>
+        </p:spPr>
+        <p:txBody>
+          <a:bodyPr wrap="square"/>
+          <a:lstStyle/>
+          <a:p>
+            <a:pPr marL="285750" indent="-171450">
+              <a:buChar char="•"/>
+            </a:pPr>
+            <a:r>
+              <a:rPr lang="en-US" sz="1720">
+                <a:solidFill>
+                  <a:srgbClr val="172033"/>
+                </a:solidFill>
+              </a:rPr>
+              <a:t>Bountix turns informal task and service requests into secure, trackable transactions</a:t>
+            </a:r>
+          </a:p>
+          <a:p>
+            <a:pPr marL="285750" indent="-171450">
+              <a:buChar char="•"/>
+            </a:pPr>
+            <a:r>
+              <a:rPr lang="en-US" sz="1720">
+                <a:solidFill>
+                  <a:srgbClr val="172033"/>
+                </a:solidFill>
+              </a:rPr>
+              <a:t>Requesters can post tasks, while creators and taskers can also publish service offers</a:t>
+            </a:r>
+          </a:p>
+          <a:p>
+            <a:pPr marL="285750" indent="-171450">
+              <a:buChar char="•"/>
+            </a:pPr>
+            <a:r>
+              <a:rPr lang="en-US" sz="1720">
+                <a:solidFill>
+                  <a:srgbClr val="172033"/>
+                </a:solidFill>
+              </a:rPr>
+              <a:t>Accepted participants coordinate work with chat, notifications, and task status tracking</a:t>
+            </a:r>
+          </a:p>
+          <a:p>
+            <a:pPr marL="285750" indent="-171450">
+              <a:buChar char="•"/>
+            </a:pPr>
+            <a:r>
+              <a:rPr lang="en-US" sz="1720">
                 <a:solidFill>
                   <a:srgbClr val="172033"/>
                 </a:solidFill>
               </a:rPr>
               <a:t>Escrow is released only after completion is approved by the requester or admin</a:t>
+            </a:r>
+          </a:p>
+        </p:txBody>
+      </p:sp>
+      <p:sp>
+        <p:nvSpPr>
+          <p:cNvPr id="230" name="Panel 230"/>
+          <p:cNvSpPr/>
+          <p:nvPr/>
+        </p:nvSpPr>
+        <p:spPr>
+          <a:xfrm>
+            <a:off x="6955000" y="1395000"/>
+            <a:ext cx="1510000" cy="3245000"/>
+          </a:xfrm>
+          <a:prstGeom prst="roundRect">
+            <a:avLst/>
+          </a:prstGeom>
+          <a:solidFill>
+            <a:srgbClr val="FFFFFF"/>
+          </a:solidFill>
+          <a:ln>
+            <a:noFill/>
+          </a:ln>
+        </p:spPr>
+      </p:sp>
+      <p:pic>
+        <p:nvPicPr>
+          <p:cNvPr id="30" name="Service Offers"/>
+          <p:cNvPicPr>
+            <a:picLocks noChangeAspect="1"/>
+          </p:cNvPicPr>
+          <p:nvPr/>
+        </p:nvPicPr>
+        <p:blipFill>
+          <a:blip r:embed="rId1"/>
+          <a:stretch>
+            <a:fillRect/>
+          </a:stretch>
+        </p:blipFill>
+        <p:spPr>
+          <a:xfrm>
+            <a:off x="7000000" y="1440000"/>
+            <a:ext cx="1420000" cy="3155000"/>
+          </a:xfrm>
+          <a:prstGeom prst="roundRect">
+            <a:avLst/>
+          </a:prstGeom>
+          <a:ln w="12700">
+            <a:solidFill>
+              <a:srgbClr val="E5E7EB"/>
+            </a:solidFill>
+          </a:ln>
+        </p:spPr>
+      </p:pic>
+      <p:sp>
+        <p:nvSpPr>
+          <p:cNvPr id="130" name="Text 130"/>
+          <p:cNvSpPr txBox="1"/>
+          <p:nvPr/>
+        </p:nvSpPr>
+        <p:spPr>
+          <a:xfrm>
+            <a:off x="7000000" y="4685000"/>
+            <a:ext cx="1420000" cy="240000"/>
+          </a:xfrm>
+          <a:prstGeom prst="rect">
+            <a:avLst/>
+          </a:prstGeom>
+          <a:noFill/>
+        </p:spPr>
+        <p:txBody>
+          <a:bodyPr wrap="square"/>
+          <a:lstStyle/>
+          <a:p>
+            <a:pPr>
+              <a:buNone/>
+            </a:pPr>
+            <a:r>
+              <a:rPr lang="en-US" sz="950">
+                <a:solidFill>
+                  <a:srgbClr val="4B5563"/>
+                </a:solidFill>
+              </a:rPr>
+              <a:t>Service Offers</a:t>
             </a:r>
           </a:p>
         </p:txBody>
@@ -1150,23 +1320,23 @@
         </p:nvSpPr>
         <p:spPr>
           <a:xfrm>
-            <a:off x="780000" y="1840000"/>
-            <a:ext cx="7600000" cy="3600000"/>
-          </a:xfrm>
-          <a:prstGeom prst="rect">
-            <a:avLst/>
-          </a:prstGeom>
-          <a:noFill/>
-        </p:spPr>
-        <p:txBody>
-          <a:bodyPr wrap="square"/>
-          <a:lstStyle/>
-          <a:p>
-            <a:pPr marL="285750" indent="-171450">
-              <a:buChar char="•"/>
-            </a:pPr>
-            <a:r>
-              <a:rPr lang="en-US" sz="2050">
+            <a:off x="720000" y="1840000"/>
+            <a:ext cx="4050000" cy="3600000"/>
+          </a:xfrm>
+          <a:prstGeom prst="rect">
+            <a:avLst/>
+          </a:prstGeom>
+          <a:noFill/>
+        </p:spPr>
+        <p:txBody>
+          <a:bodyPr wrap="square"/>
+          <a:lstStyle/>
+          <a:p>
+            <a:pPr marL="285750" indent="-171450">
+              <a:buChar char="•"/>
+            </a:pPr>
+            <a:r>
+              <a:rPr lang="en-US" sz="1720">
                 <a:solidFill>
                   <a:srgbClr val="172033"/>
                 </a:solidFill>
@@ -1179,7 +1349,7 @@
               <a:buChar char="•"/>
             </a:pPr>
             <a:r>
-              <a:rPr lang="en-US" sz="2050">
+              <a:rPr lang="en-US" sz="1720">
                 <a:solidFill>
                   <a:srgbClr val="172033"/>
                 </a:solidFill>
@@ -1192,7 +1362,7 @@
               <a:buChar char="•"/>
             </a:pPr>
             <a:r>
-              <a:rPr lang="en-US" sz="2050">
+              <a:rPr lang="en-US" sz="1720">
                 <a:solidFill>
                   <a:srgbClr val="172033"/>
                 </a:solidFill>
@@ -1205,7 +1375,7 @@
               <a:buChar char="•"/>
             </a:pPr>
             <a:r>
-              <a:rPr lang="en-US" sz="2050">
+              <a:rPr lang="en-US" sz="1720">
                 <a:solidFill>
                   <a:srgbClr val="172033"/>
                 </a:solidFill>
@@ -1218,12 +1388,267 @@
               <a:buChar char="•"/>
             </a:pPr>
             <a:r>
-              <a:rPr lang="en-US" sz="2050">
+              <a:rPr lang="en-US" sz="1720">
                 <a:solidFill>
                   <a:srgbClr val="172033"/>
                 </a:solidFill>
               </a:rPr>
               <a:t>Requester or admin releases escrow and the tasker sees the payout in wallet history</a:t>
+            </a:r>
+          </a:p>
+        </p:txBody>
+      </p:sp>
+      <p:sp>
+        <p:nvSpPr>
+          <p:cNvPr id="230" name="Panel 230"/>
+          <p:cNvSpPr/>
+          <p:nvPr/>
+        </p:nvSpPr>
+        <p:spPr>
+          <a:xfrm>
+            <a:off x="4875000" y="1715000"/>
+            <a:ext cx="1150000" cy="2445000"/>
+          </a:xfrm>
+          <a:prstGeom prst="roundRect">
+            <a:avLst/>
+          </a:prstGeom>
+          <a:solidFill>
+            <a:srgbClr val="FFFFFF"/>
+          </a:solidFill>
+          <a:ln>
+            <a:noFill/>
+          </a:ln>
+        </p:spPr>
+      </p:sp>
+      <p:pic>
+        <p:nvPicPr>
+          <p:cNvPr id="30" name="Browse Tasks"/>
+          <p:cNvPicPr>
+            <a:picLocks noChangeAspect="1"/>
+          </p:cNvPicPr>
+          <p:nvPr/>
+        </p:nvPicPr>
+        <p:blipFill>
+          <a:blip r:embed="rId1"/>
+          <a:stretch>
+            <a:fillRect/>
+          </a:stretch>
+        </p:blipFill>
+        <p:spPr>
+          <a:xfrm>
+            <a:off x="4920000" y="1760000"/>
+            <a:ext cx="1060000" cy="2355000"/>
+          </a:xfrm>
+          <a:prstGeom prst="roundRect">
+            <a:avLst/>
+          </a:prstGeom>
+          <a:ln w="12700">
+            <a:solidFill>
+              <a:srgbClr val="E5E7EB"/>
+            </a:solidFill>
+          </a:ln>
+        </p:spPr>
+      </p:pic>
+      <p:sp>
+        <p:nvSpPr>
+          <p:cNvPr id="130" name="Text 130"/>
+          <p:cNvSpPr txBox="1"/>
+          <p:nvPr/>
+        </p:nvSpPr>
+        <p:spPr>
+          <a:xfrm>
+            <a:off x="4920000" y="4205000"/>
+            <a:ext cx="1060000" cy="240000"/>
+          </a:xfrm>
+          <a:prstGeom prst="rect">
+            <a:avLst/>
+          </a:prstGeom>
+          <a:noFill/>
+        </p:spPr>
+        <p:txBody>
+          <a:bodyPr wrap="square"/>
+          <a:lstStyle/>
+          <a:p>
+            <a:pPr>
+              <a:buNone/>
+            </a:pPr>
+            <a:r>
+              <a:rPr lang="en-US" sz="950">
+                <a:solidFill>
+                  <a:srgbClr val="4B5563"/>
+                </a:solidFill>
+              </a:rPr>
+              <a:t>Browse Tasks</a:t>
+            </a:r>
+          </a:p>
+        </p:txBody>
+      </p:sp>
+      <p:sp>
+        <p:nvSpPr>
+          <p:cNvPr id="231" name="Panel 231"/>
+          <p:cNvSpPr/>
+          <p:nvPr/>
+        </p:nvSpPr>
+        <p:spPr>
+          <a:xfrm>
+            <a:off x="6155000" y="1715000"/>
+            <a:ext cx="1150000" cy="2445000"/>
+          </a:xfrm>
+          <a:prstGeom prst="roundRect">
+            <a:avLst/>
+          </a:prstGeom>
+          <a:solidFill>
+            <a:srgbClr val="FFFFFF"/>
+          </a:solidFill>
+          <a:ln>
+            <a:noFill/>
+          </a:ln>
+        </p:spPr>
+      </p:sp>
+      <p:pic>
+        <p:nvPicPr>
+          <p:cNvPr id="31" name="Release Escrow"/>
+          <p:cNvPicPr>
+            <a:picLocks noChangeAspect="1"/>
+          </p:cNvPicPr>
+          <p:nvPr/>
+        </p:nvPicPr>
+        <p:blipFill>
+          <a:blip r:embed="rId2"/>
+          <a:stretch>
+            <a:fillRect/>
+          </a:stretch>
+        </p:blipFill>
+        <p:spPr>
+          <a:xfrm>
+            <a:off x="6200000" y="1760000"/>
+            <a:ext cx="1060000" cy="2355000"/>
+          </a:xfrm>
+          <a:prstGeom prst="roundRect">
+            <a:avLst/>
+          </a:prstGeom>
+          <a:ln w="12700">
+            <a:solidFill>
+              <a:srgbClr val="E5E7EB"/>
+            </a:solidFill>
+          </a:ln>
+        </p:spPr>
+      </p:pic>
+      <p:sp>
+        <p:nvSpPr>
+          <p:cNvPr id="131" name="Text 131"/>
+          <p:cNvSpPr txBox="1"/>
+          <p:nvPr/>
+        </p:nvSpPr>
+        <p:spPr>
+          <a:xfrm>
+            <a:off x="6200000" y="4205000"/>
+            <a:ext cx="1060000" cy="240000"/>
+          </a:xfrm>
+          <a:prstGeom prst="rect">
+            <a:avLst/>
+          </a:prstGeom>
+          <a:noFill/>
+        </p:spPr>
+        <p:txBody>
+          <a:bodyPr wrap="square"/>
+          <a:lstStyle/>
+          <a:p>
+            <a:pPr>
+              <a:buNone/>
+            </a:pPr>
+            <a:r>
+              <a:rPr lang="en-US" sz="950">
+                <a:solidFill>
+                  <a:srgbClr val="4B5563"/>
+                </a:solidFill>
+              </a:rPr>
+              <a:t>Release Escrow</a:t>
+            </a:r>
+          </a:p>
+        </p:txBody>
+      </p:sp>
+      <p:sp>
+        <p:nvSpPr>
+          <p:cNvPr id="232" name="Panel 232"/>
+          <p:cNvSpPr/>
+          <p:nvPr/>
+        </p:nvSpPr>
+        <p:spPr>
+          <a:xfrm>
+            <a:off x="7435000" y="1715000"/>
+            <a:ext cx="1150000" cy="2445000"/>
+          </a:xfrm>
+          <a:prstGeom prst="roundRect">
+            <a:avLst/>
+          </a:prstGeom>
+          <a:solidFill>
+            <a:srgbClr val="FFFFFF"/>
+          </a:solidFill>
+          <a:ln>
+            <a:noFill/>
+          </a:ln>
+        </p:spPr>
+      </p:sp>
+      <p:pic>
+        <p:nvPicPr>
+          <p:cNvPr id="32" name="Payout History"/>
+          <p:cNvPicPr>
+            <a:picLocks noChangeAspect="1"/>
+          </p:cNvPicPr>
+          <p:nvPr/>
+        </p:nvPicPr>
+        <p:blipFill>
+          <a:blip r:embed="rId3"/>
+          <a:stretch>
+            <a:fillRect/>
+          </a:stretch>
+        </p:blipFill>
+        <p:spPr>
+          <a:xfrm>
+            <a:off x="7480000" y="1760000"/>
+            <a:ext cx="1060000" cy="2355000"/>
+          </a:xfrm>
+          <a:prstGeom prst="roundRect">
+            <a:avLst/>
+          </a:prstGeom>
+          <a:ln w="12700">
+            <a:solidFill>
+              <a:srgbClr val="E5E7EB"/>
+            </a:solidFill>
+          </a:ln>
+        </p:spPr>
+      </p:pic>
+      <p:sp>
+        <p:nvSpPr>
+          <p:cNvPr id="132" name="Text 132"/>
+          <p:cNvSpPr txBox="1"/>
+          <p:nvPr/>
+        </p:nvSpPr>
+        <p:spPr>
+          <a:xfrm>
+            <a:off x="7480000" y="4205000"/>
+            <a:ext cx="1060000" cy="240000"/>
+          </a:xfrm>
+          <a:prstGeom prst="rect">
+            <a:avLst/>
+          </a:prstGeom>
+          <a:noFill/>
+        </p:spPr>
+        <p:txBody>
+          <a:bodyPr wrap="square"/>
+          <a:lstStyle/>
+          <a:p>
+            <a:pPr>
+              <a:buNone/>
+            </a:pPr>
+            <a:r>
+              <a:rPr lang="en-US" sz="950">
+                <a:solidFill>
+                  <a:srgbClr val="4B5563"/>
+                </a:solidFill>
+              </a:rPr>
+              <a:t>Payout History</a:t>
             </a:r>
           </a:p>
         </p:txBody>
@@ -1403,23 +1828,23 @@
         </p:nvSpPr>
         <p:spPr>
           <a:xfrm>
-            <a:off x="780000" y="1840000"/>
-            <a:ext cx="7600000" cy="3600000"/>
-          </a:xfrm>
-          <a:prstGeom prst="rect">
-            <a:avLst/>
-          </a:prstGeom>
-          <a:noFill/>
-        </p:spPr>
-        <p:txBody>
-          <a:bodyPr wrap="square"/>
-          <a:lstStyle/>
-          <a:p>
-            <a:pPr marL="285750" indent="-171450">
-              <a:buChar char="•"/>
-            </a:pPr>
-            <a:r>
-              <a:rPr lang="en-US" sz="2050">
+            <a:off x="720000" y="1840000"/>
+            <a:ext cx="4050000" cy="3600000"/>
+          </a:xfrm>
+          <a:prstGeom prst="rect">
+            <a:avLst/>
+          </a:prstGeom>
+          <a:noFill/>
+        </p:spPr>
+        <p:txBody>
+          <a:bodyPr wrap="square"/>
+          <a:lstStyle/>
+          <a:p>
+            <a:pPr marL="285750" indent="-171450">
+              <a:buChar char="•"/>
+            </a:pPr>
+            <a:r>
+              <a:rPr lang="en-US" sz="1720">
                 <a:solidFill>
                   <a:srgbClr val="172033"/>
                 </a:solidFill>
@@ -1432,7 +1857,7 @@
               <a:buChar char="•"/>
             </a:pPr>
             <a:r>
-              <a:rPr lang="en-US" sz="2050">
+              <a:rPr lang="en-US" sz="1720">
                 <a:solidFill>
                   <a:srgbClr val="172033"/>
                 </a:solidFill>
@@ -1445,7 +1870,7 @@
               <a:buChar char="•"/>
             </a:pPr>
             <a:r>
-              <a:rPr lang="en-US" sz="2050">
+              <a:rPr lang="en-US" sz="1720">
                 <a:solidFill>
                   <a:srgbClr val="172033"/>
                 </a:solidFill>
@@ -1458,7 +1883,7 @@
               <a:buChar char="•"/>
             </a:pPr>
             <a:r>
-              <a:rPr lang="en-US" sz="2050">
+              <a:rPr lang="en-US" sz="1720">
                 <a:solidFill>
                   <a:srgbClr val="172033"/>
                 </a:solidFill>
@@ -1471,12 +1896,97 @@
               <a:buChar char="•"/>
             </a:pPr>
             <a:r>
-              <a:rPr lang="en-US" sz="2050">
+              <a:rPr lang="en-US" sz="1720">
                 <a:solidFill>
                   <a:srgbClr val="172033"/>
                 </a:solidFill>
               </a:rPr>
               <a:t>Stellar creates a practical payment rail for real-world consumer applications</a:t>
+            </a:r>
+          </a:p>
+        </p:txBody>
+      </p:sp>
+      <p:sp>
+        <p:nvSpPr>
+          <p:cNvPr id="230" name="Panel 230"/>
+          <p:cNvSpPr/>
+          <p:nvPr/>
+        </p:nvSpPr>
+        <p:spPr>
+          <a:xfrm>
+            <a:off x="6955000" y="1395000"/>
+            <a:ext cx="1510000" cy="3245000"/>
+          </a:xfrm>
+          <a:prstGeom prst="roundRect">
+            <a:avLst/>
+          </a:prstGeom>
+          <a:solidFill>
+            <a:srgbClr val="FFFFFF"/>
+          </a:solidFill>
+          <a:ln>
+            <a:noFill/>
+          </a:ln>
+        </p:spPr>
+      </p:sp>
+      <p:pic>
+        <p:nvPicPr>
+          <p:cNvPr id="30" name="USDC Payouts"/>
+          <p:cNvPicPr>
+            <a:picLocks noChangeAspect="1"/>
+          </p:cNvPicPr>
+          <p:nvPr/>
+        </p:nvPicPr>
+        <p:blipFill>
+          <a:blip r:embed="rId1"/>
+          <a:stretch>
+            <a:fillRect/>
+          </a:stretch>
+        </p:blipFill>
+        <p:spPr>
+          <a:xfrm>
+            <a:off x="7000000" y="1440000"/>
+            <a:ext cx="1420000" cy="3155000"/>
+          </a:xfrm>
+          <a:prstGeom prst="roundRect">
+            <a:avLst/>
+          </a:prstGeom>
+          <a:ln w="12700">
+            <a:solidFill>
+              <a:srgbClr val="E5E7EB"/>
+            </a:solidFill>
+          </a:ln>
+        </p:spPr>
+      </p:pic>
+      <p:sp>
+        <p:nvSpPr>
+          <p:cNvPr id="130" name="Text 130"/>
+          <p:cNvSpPr txBox="1"/>
+          <p:nvPr/>
+        </p:nvSpPr>
+        <p:spPr>
+          <a:xfrm>
+            <a:off x="7000000" y="4685000"/>
+            <a:ext cx="1420000" cy="240000"/>
+          </a:xfrm>
+          <a:prstGeom prst="rect">
+            <a:avLst/>
+          </a:prstGeom>
+          <a:noFill/>
+        </p:spPr>
+        <p:txBody>
+          <a:bodyPr wrap="square"/>
+          <a:lstStyle/>
+          <a:p>
+            <a:pPr>
+              <a:buNone/>
+            </a:pPr>
+            <a:r>
+              <a:rPr lang="en-US" sz="950">
+                <a:solidFill>
+                  <a:srgbClr val="4B5563"/>
+                </a:solidFill>
+              </a:rPr>
+              <a:t>USDC Payouts</a:t>
             </a:r>
           </a:p>
         </p:txBody>
@@ -1656,36 +2166,36 @@
         </p:nvSpPr>
         <p:spPr>
           <a:xfrm>
-            <a:off x="780000" y="1840000"/>
-            <a:ext cx="7600000" cy="3600000"/>
-          </a:xfrm>
-          <a:prstGeom prst="rect">
-            <a:avLst/>
-          </a:prstGeom>
-          <a:noFill/>
-        </p:spPr>
-        <p:txBody>
-          <a:bodyPr wrap="square"/>
-          <a:lstStyle/>
-          <a:p>
-            <a:pPr marL="285750" indent="-171450">
-              <a:buChar char="•"/>
-            </a:pPr>
-            <a:r>
-              <a:rPr lang="en-US" sz="2050">
-                <a:solidFill>
-                  <a:srgbClr val="172033"/>
-                </a:solidFill>
-              </a:rPr>
-              <a:t>Task creation, browsing, applications, and acceptance flow</a:t>
-            </a:r>
-          </a:p>
-          <a:p>
-            <a:pPr marL="285750" indent="-171450">
-              <a:buChar char="•"/>
-            </a:pPr>
-            <a:r>
-              <a:rPr lang="en-US" sz="2050">
+            <a:off x="720000" y="1840000"/>
+            <a:ext cx="4050000" cy="3600000"/>
+          </a:xfrm>
+          <a:prstGeom prst="rect">
+            <a:avLst/>
+          </a:prstGeom>
+          <a:noFill/>
+        </p:spPr>
+        <p:txBody>
+          <a:bodyPr wrap="square"/>
+          <a:lstStyle/>
+          <a:p>
+            <a:pPr marL="285750" indent="-171450">
+              <a:buChar char="•"/>
+            </a:pPr>
+            <a:r>
+              <a:rPr lang="en-US" sz="1720">
+                <a:solidFill>
+                  <a:srgbClr val="172033"/>
+                </a:solidFill>
+              </a:rPr>
+              <a:t>Task creation, browsing, applications, acceptance flow, and service offers</a:t>
+            </a:r>
+          </a:p>
+          <a:p>
+            <a:pPr marL="285750" indent="-171450">
+              <a:buChar char="•"/>
+            </a:pPr>
+            <a:r>
+              <a:rPr lang="en-US" sz="1720">
                 <a:solidFill>
                   <a:srgbClr val="172033"/>
                 </a:solidFill>
@@ -1698,7 +2208,7 @@
               <a:buChar char="•"/>
             </a:pPr>
             <a:r>
-              <a:rPr lang="en-US" sz="2050">
+              <a:rPr lang="en-US" sz="1720">
                 <a:solidFill>
                   <a:srgbClr val="172033"/>
                 </a:solidFill>
@@ -1711,7 +2221,7 @@
               <a:buChar char="•"/>
             </a:pPr>
             <a:r>
-              <a:rPr lang="en-US" sz="2050">
+              <a:rPr lang="en-US" sz="1720">
                 <a:solidFill>
                   <a:srgbClr val="172033"/>
                 </a:solidFill>
@@ -1724,12 +2234,352 @@
               <a:buChar char="•"/>
             </a:pPr>
             <a:r>
-              <a:rPr lang="en-US" sz="2050">
+              <a:rPr lang="en-US" sz="1720">
                 <a:solidFill>
                   <a:srgbClr val="172033"/>
                 </a:solidFill>
               </a:rPr>
               <a:t>Admin moderation with task removal reason and wallet transaction history</a:t>
+            </a:r>
+          </a:p>
+        </p:txBody>
+      </p:sp>
+      <p:sp>
+        <p:nvSpPr>
+          <p:cNvPr id="230" name="Panel 230"/>
+          <p:cNvSpPr/>
+          <p:nvPr/>
+        </p:nvSpPr>
+        <p:spPr>
+          <a:xfrm>
+            <a:off x="4615000" y="1615000"/>
+            <a:ext cx="1010000" cy="2135000"/>
+          </a:xfrm>
+          <a:prstGeom prst="roundRect">
+            <a:avLst/>
+          </a:prstGeom>
+          <a:solidFill>
+            <a:srgbClr val="FFFFFF"/>
+          </a:solidFill>
+          <a:ln>
+            <a:noFill/>
+          </a:ln>
+        </p:spPr>
+      </p:sp>
+      <p:pic>
+        <p:nvPicPr>
+          <p:cNvPr id="30" name="Home"/>
+          <p:cNvPicPr>
+            <a:picLocks noChangeAspect="1"/>
+          </p:cNvPicPr>
+          <p:nvPr/>
+        </p:nvPicPr>
+        <p:blipFill>
+          <a:blip r:embed="rId1"/>
+          <a:stretch>
+            <a:fillRect/>
+          </a:stretch>
+        </p:blipFill>
+        <p:spPr>
+          <a:xfrm>
+            <a:off x="4660000" y="1660000"/>
+            <a:ext cx="920000" cy="2045000"/>
+          </a:xfrm>
+          <a:prstGeom prst="roundRect">
+            <a:avLst/>
+          </a:prstGeom>
+          <a:ln w="12700">
+            <a:solidFill>
+              <a:srgbClr val="E5E7EB"/>
+            </a:solidFill>
+          </a:ln>
+        </p:spPr>
+      </p:pic>
+      <p:sp>
+        <p:nvSpPr>
+          <p:cNvPr id="130" name="Text 130"/>
+          <p:cNvSpPr txBox="1"/>
+          <p:nvPr/>
+        </p:nvSpPr>
+        <p:spPr>
+          <a:xfrm>
+            <a:off x="4660000" y="3795000"/>
+            <a:ext cx="920000" cy="240000"/>
+          </a:xfrm>
+          <a:prstGeom prst="rect">
+            <a:avLst/>
+          </a:prstGeom>
+          <a:noFill/>
+        </p:spPr>
+        <p:txBody>
+          <a:bodyPr wrap="square"/>
+          <a:lstStyle/>
+          <a:p>
+            <a:pPr>
+              <a:buNone/>
+            </a:pPr>
+            <a:r>
+              <a:rPr lang="en-US" sz="950">
+                <a:solidFill>
+                  <a:srgbClr val="4B5563"/>
+                </a:solidFill>
+              </a:rPr>
+              <a:t>Home</a:t>
+            </a:r>
+          </a:p>
+        </p:txBody>
+      </p:sp>
+      <p:sp>
+        <p:nvSpPr>
+          <p:cNvPr id="231" name="Panel 231"/>
+          <p:cNvSpPr/>
+          <p:nvPr/>
+        </p:nvSpPr>
+        <p:spPr>
+          <a:xfrm>
+            <a:off x="5755000" y="1615000"/>
+            <a:ext cx="1010000" cy="2135000"/>
+          </a:xfrm>
+          <a:prstGeom prst="roundRect">
+            <a:avLst/>
+          </a:prstGeom>
+          <a:solidFill>
+            <a:srgbClr val="FFFFFF"/>
+          </a:solidFill>
+          <a:ln>
+            <a:noFill/>
+          </a:ln>
+        </p:spPr>
+      </p:sp>
+      <p:pic>
+        <p:nvPicPr>
+          <p:cNvPr id="31" name="Tasks"/>
+          <p:cNvPicPr>
+            <a:picLocks noChangeAspect="1"/>
+          </p:cNvPicPr>
+          <p:nvPr/>
+        </p:nvPicPr>
+        <p:blipFill>
+          <a:blip r:embed="rId2"/>
+          <a:stretch>
+            <a:fillRect/>
+          </a:stretch>
+        </p:blipFill>
+        <p:spPr>
+          <a:xfrm>
+            <a:off x="5800000" y="1660000"/>
+            <a:ext cx="920000" cy="2045000"/>
+          </a:xfrm>
+          <a:prstGeom prst="roundRect">
+            <a:avLst/>
+          </a:prstGeom>
+          <a:ln w="12700">
+            <a:solidFill>
+              <a:srgbClr val="E5E7EB"/>
+            </a:solidFill>
+          </a:ln>
+        </p:spPr>
+      </p:pic>
+      <p:sp>
+        <p:nvSpPr>
+          <p:cNvPr id="131" name="Text 131"/>
+          <p:cNvSpPr txBox="1"/>
+          <p:nvPr/>
+        </p:nvSpPr>
+        <p:spPr>
+          <a:xfrm>
+            <a:off x="5800000" y="3795000"/>
+            <a:ext cx="920000" cy="240000"/>
+          </a:xfrm>
+          <a:prstGeom prst="rect">
+            <a:avLst/>
+          </a:prstGeom>
+          <a:noFill/>
+        </p:spPr>
+        <p:txBody>
+          <a:bodyPr wrap="square"/>
+          <a:lstStyle/>
+          <a:p>
+            <a:pPr>
+              <a:buNone/>
+            </a:pPr>
+            <a:r>
+              <a:rPr lang="en-US" sz="950">
+                <a:solidFill>
+                  <a:srgbClr val="4B5563"/>
+                </a:solidFill>
+              </a:rPr>
+              <a:t>Tasks</a:t>
+            </a:r>
+          </a:p>
+        </p:txBody>
+      </p:sp>
+      <p:sp>
+        <p:nvSpPr>
+          <p:cNvPr id="232" name="Panel 232"/>
+          <p:cNvSpPr/>
+          <p:nvPr/>
+        </p:nvSpPr>
+        <p:spPr>
+          <a:xfrm>
+            <a:off x="6895000" y="1615000"/>
+            <a:ext cx="1010000" cy="2135000"/>
+          </a:xfrm>
+          <a:prstGeom prst="roundRect">
+            <a:avLst/>
+          </a:prstGeom>
+          <a:solidFill>
+            <a:srgbClr val="FFFFFF"/>
+          </a:solidFill>
+          <a:ln>
+            <a:noFill/>
+          </a:ln>
+        </p:spPr>
+      </p:sp>
+      <p:pic>
+        <p:nvPicPr>
+          <p:cNvPr id="32" name="Services"/>
+          <p:cNvPicPr>
+            <a:picLocks noChangeAspect="1"/>
+          </p:cNvPicPr>
+          <p:nvPr/>
+        </p:nvPicPr>
+        <p:blipFill>
+          <a:blip r:embed="rId3"/>
+          <a:stretch>
+            <a:fillRect/>
+          </a:stretch>
+        </p:blipFill>
+        <p:spPr>
+          <a:xfrm>
+            <a:off x="6940000" y="1660000"/>
+            <a:ext cx="920000" cy="2045000"/>
+          </a:xfrm>
+          <a:prstGeom prst="roundRect">
+            <a:avLst/>
+          </a:prstGeom>
+          <a:ln w="12700">
+            <a:solidFill>
+              <a:srgbClr val="E5E7EB"/>
+            </a:solidFill>
+          </a:ln>
+        </p:spPr>
+      </p:pic>
+      <p:sp>
+        <p:nvSpPr>
+          <p:cNvPr id="132" name="Text 132"/>
+          <p:cNvSpPr txBox="1"/>
+          <p:nvPr/>
+        </p:nvSpPr>
+        <p:spPr>
+          <a:xfrm>
+            <a:off x="6940000" y="3795000"/>
+            <a:ext cx="920000" cy="240000"/>
+          </a:xfrm>
+          <a:prstGeom prst="rect">
+            <a:avLst/>
+          </a:prstGeom>
+          <a:noFill/>
+        </p:spPr>
+        <p:txBody>
+          <a:bodyPr wrap="square"/>
+          <a:lstStyle/>
+          <a:p>
+            <a:pPr>
+              <a:buNone/>
+            </a:pPr>
+            <a:r>
+              <a:rPr lang="en-US" sz="950">
+                <a:solidFill>
+                  <a:srgbClr val="4B5563"/>
+                </a:solidFill>
+              </a:rPr>
+              <a:t>Services</a:t>
+            </a:r>
+          </a:p>
+        </p:txBody>
+      </p:sp>
+      <p:sp>
+        <p:nvSpPr>
+          <p:cNvPr id="233" name="Panel 233"/>
+          <p:cNvSpPr/>
+          <p:nvPr/>
+        </p:nvSpPr>
+        <p:spPr>
+          <a:xfrm>
+            <a:off x="8035000" y="1615000"/>
+            <a:ext cx="1010000" cy="2135000"/>
+          </a:xfrm>
+          <a:prstGeom prst="roundRect">
+            <a:avLst/>
+          </a:prstGeom>
+          <a:solidFill>
+            <a:srgbClr val="FFFFFF"/>
+          </a:solidFill>
+          <a:ln>
+            <a:noFill/>
+          </a:ln>
+        </p:spPr>
+      </p:sp>
+      <p:pic>
+        <p:nvPicPr>
+          <p:cNvPr id="33" name="Wallet Unlock"/>
+          <p:cNvPicPr>
+            <a:picLocks noChangeAspect="1"/>
+          </p:cNvPicPr>
+          <p:nvPr/>
+        </p:nvPicPr>
+        <p:blipFill>
+          <a:blip r:embed="rId4"/>
+          <a:stretch>
+            <a:fillRect/>
+          </a:stretch>
+        </p:blipFill>
+        <p:spPr>
+          <a:xfrm>
+            <a:off x="8080000" y="1660000"/>
+            <a:ext cx="920000" cy="2045000"/>
+          </a:xfrm>
+          <a:prstGeom prst="roundRect">
+            <a:avLst/>
+          </a:prstGeom>
+          <a:ln w="12700">
+            <a:solidFill>
+              <a:srgbClr val="E5E7EB"/>
+            </a:solidFill>
+          </a:ln>
+        </p:spPr>
+      </p:pic>
+      <p:sp>
+        <p:nvSpPr>
+          <p:cNvPr id="133" name="Text 133"/>
+          <p:cNvSpPr txBox="1"/>
+          <p:nvPr/>
+        </p:nvSpPr>
+        <p:spPr>
+          <a:xfrm>
+            <a:off x="8080000" y="3795000"/>
+            <a:ext cx="920000" cy="240000"/>
+          </a:xfrm>
+          <a:prstGeom prst="rect">
+            <a:avLst/>
+          </a:prstGeom>
+          <a:noFill/>
+        </p:spPr>
+        <p:txBody>
+          <a:bodyPr wrap="square"/>
+          <a:lstStyle/>
+          <a:p>
+            <a:pPr>
+              <a:buNone/>
+            </a:pPr>
+            <a:r>
+              <a:rPr lang="en-US" sz="950">
+                <a:solidFill>
+                  <a:srgbClr val="4B5563"/>
+                </a:solidFill>
+              </a:rPr>
+              <a:t>Wallet Unlock</a:t>
             </a:r>
           </a:p>
         </p:txBody>
@@ -1943,7 +2793,7 @@
                   <a:srgbClr val="172033"/>
                 </a:solidFill>
               </a:rPr>
-              <a:t>Taskers who want short-term income with clearer payment protection</a:t>
+              <a:t>Taskers and service providers who want short-term income with clearer payment protection</a:t>
             </a:r>
           </a:p>
           <a:p>
@@ -2149,23 +2999,23 @@
         </p:nvSpPr>
         <p:spPr>
           <a:xfrm>
-            <a:off x="780000" y="1840000"/>
-            <a:ext cx="7600000" cy="3600000"/>
-          </a:xfrm>
-          <a:prstGeom prst="rect">
-            <a:avLst/>
-          </a:prstGeom>
-          <a:noFill/>
-        </p:spPr>
-        <p:txBody>
-          <a:bodyPr wrap="square"/>
-          <a:lstStyle/>
-          <a:p>
-            <a:pPr marL="285750" indent="-171450">
-              <a:buChar char="•"/>
-            </a:pPr>
-            <a:r>
-              <a:rPr lang="en-US" sz="2050">
+            <a:off x="720000" y="1840000"/>
+            <a:ext cx="4050000" cy="3600000"/>
+          </a:xfrm>
+          <a:prstGeom prst="rect">
+            <a:avLst/>
+          </a:prstGeom>
+          <a:noFill/>
+        </p:spPr>
+        <p:txBody>
+          <a:bodyPr wrap="square"/>
+          <a:lstStyle/>
+          <a:p>
+            <a:pPr marL="285750" indent="-171450">
+              <a:buChar char="•"/>
+            </a:pPr>
+            <a:r>
+              <a:rPr lang="en-US" sz="1720">
                 <a:solidFill>
                   <a:srgbClr val="172033"/>
                 </a:solidFill>
@@ -2178,7 +3028,7 @@
               <a:buChar char="•"/>
             </a:pPr>
             <a:r>
-              <a:rPr lang="en-US" sz="2050">
+              <a:rPr lang="en-US" sz="1720">
                 <a:solidFill>
                   <a:srgbClr val="172033"/>
                 </a:solidFill>
@@ -2191,7 +3041,7 @@
               <a:buChar char="•"/>
             </a:pPr>
             <a:r>
-              <a:rPr lang="en-US" sz="2050">
+              <a:rPr lang="en-US" sz="1720">
                 <a:solidFill>
                   <a:srgbClr val="172033"/>
                 </a:solidFill>
@@ -2204,7 +3054,7 @@
               <a:buChar char="•"/>
             </a:pPr>
             <a:r>
-              <a:rPr lang="en-US" sz="2050">
+              <a:rPr lang="en-US" sz="1720">
                 <a:solidFill>
                   <a:srgbClr val="172033"/>
                 </a:solidFill>
@@ -2217,12 +3067,267 @@
               <a:buChar char="•"/>
             </a:pPr>
             <a:r>
-              <a:rPr lang="en-US" sz="2050">
+              <a:rPr lang="en-US" sz="1720">
                 <a:solidFill>
                   <a:srgbClr val="172033"/>
                 </a:solidFill>
               </a:rPr>
               <a:t>Tasker wallet shows recent transaction history after release</a:t>
+            </a:r>
+          </a:p>
+        </p:txBody>
+      </p:sp>
+      <p:sp>
+        <p:nvSpPr>
+          <p:cNvPr id="230" name="Panel 230"/>
+          <p:cNvSpPr/>
+          <p:nvPr/>
+        </p:nvSpPr>
+        <p:spPr>
+          <a:xfrm>
+            <a:off x="4875000" y="1715000"/>
+            <a:ext cx="1150000" cy="2445000"/>
+          </a:xfrm>
+          <a:prstGeom prst="roundRect">
+            <a:avLst/>
+          </a:prstGeom>
+          <a:solidFill>
+            <a:srgbClr val="FFFFFF"/>
+          </a:solidFill>
+          <a:ln>
+            <a:noFill/>
+          </a:ln>
+        </p:spPr>
+      </p:sp>
+      <p:pic>
+        <p:nvPicPr>
+          <p:cNvPr id="30" name="Tasks"/>
+          <p:cNvPicPr>
+            <a:picLocks noChangeAspect="1"/>
+          </p:cNvPicPr>
+          <p:nvPr/>
+        </p:nvPicPr>
+        <p:blipFill>
+          <a:blip r:embed="rId1"/>
+          <a:stretch>
+            <a:fillRect/>
+          </a:stretch>
+        </p:blipFill>
+        <p:spPr>
+          <a:xfrm>
+            <a:off x="4920000" y="1760000"/>
+            <a:ext cx="1060000" cy="2355000"/>
+          </a:xfrm>
+          <a:prstGeom prst="roundRect">
+            <a:avLst/>
+          </a:prstGeom>
+          <a:ln w="12700">
+            <a:solidFill>
+              <a:srgbClr val="E5E7EB"/>
+            </a:solidFill>
+          </a:ln>
+        </p:spPr>
+      </p:pic>
+      <p:sp>
+        <p:nvSpPr>
+          <p:cNvPr id="130" name="Text 130"/>
+          <p:cNvSpPr txBox="1"/>
+          <p:nvPr/>
+        </p:nvSpPr>
+        <p:spPr>
+          <a:xfrm>
+            <a:off x="4920000" y="4205000"/>
+            <a:ext cx="1060000" cy="240000"/>
+          </a:xfrm>
+          <a:prstGeom prst="rect">
+            <a:avLst/>
+          </a:prstGeom>
+          <a:noFill/>
+        </p:spPr>
+        <p:txBody>
+          <a:bodyPr wrap="square"/>
+          <a:lstStyle/>
+          <a:p>
+            <a:pPr>
+              <a:buNone/>
+            </a:pPr>
+            <a:r>
+              <a:rPr lang="en-US" sz="950">
+                <a:solidFill>
+                  <a:srgbClr val="4B5563"/>
+                </a:solidFill>
+              </a:rPr>
+              <a:t>Tasks</a:t>
+            </a:r>
+          </a:p>
+        </p:txBody>
+      </p:sp>
+      <p:sp>
+        <p:nvSpPr>
+          <p:cNvPr id="231" name="Panel 231"/>
+          <p:cNvSpPr/>
+          <p:nvPr/>
+        </p:nvSpPr>
+        <p:spPr>
+          <a:xfrm>
+            <a:off x="6155000" y="1715000"/>
+            <a:ext cx="1150000" cy="2445000"/>
+          </a:xfrm>
+          <a:prstGeom prst="roundRect">
+            <a:avLst/>
+          </a:prstGeom>
+          <a:solidFill>
+            <a:srgbClr val="FFFFFF"/>
+          </a:solidFill>
+          <a:ln>
+            <a:noFill/>
+          </a:ln>
+        </p:spPr>
+      </p:sp>
+      <p:pic>
+        <p:nvPicPr>
+          <p:cNvPr id="31" name="Admin Release"/>
+          <p:cNvPicPr>
+            <a:picLocks noChangeAspect="1"/>
+          </p:cNvPicPr>
+          <p:nvPr/>
+        </p:nvPicPr>
+        <p:blipFill>
+          <a:blip r:embed="rId2"/>
+          <a:stretch>
+            <a:fillRect/>
+          </a:stretch>
+        </p:blipFill>
+        <p:spPr>
+          <a:xfrm>
+            <a:off x="6200000" y="1760000"/>
+            <a:ext cx="1060000" cy="2355000"/>
+          </a:xfrm>
+          <a:prstGeom prst="roundRect">
+            <a:avLst/>
+          </a:prstGeom>
+          <a:ln w="12700">
+            <a:solidFill>
+              <a:srgbClr val="E5E7EB"/>
+            </a:solidFill>
+          </a:ln>
+        </p:spPr>
+      </p:pic>
+      <p:sp>
+        <p:nvSpPr>
+          <p:cNvPr id="131" name="Text 131"/>
+          <p:cNvSpPr txBox="1"/>
+          <p:nvPr/>
+        </p:nvSpPr>
+        <p:spPr>
+          <a:xfrm>
+            <a:off x="6200000" y="4205000"/>
+            <a:ext cx="1060000" cy="240000"/>
+          </a:xfrm>
+          <a:prstGeom prst="rect">
+            <a:avLst/>
+          </a:prstGeom>
+          <a:noFill/>
+        </p:spPr>
+        <p:txBody>
+          <a:bodyPr wrap="square"/>
+          <a:lstStyle/>
+          <a:p>
+            <a:pPr>
+              <a:buNone/>
+            </a:pPr>
+            <a:r>
+              <a:rPr lang="en-US" sz="950">
+                <a:solidFill>
+                  <a:srgbClr val="4B5563"/>
+                </a:solidFill>
+              </a:rPr>
+              <a:t>Admin Release</a:t>
+            </a:r>
+          </a:p>
+        </p:txBody>
+      </p:sp>
+      <p:sp>
+        <p:nvSpPr>
+          <p:cNvPr id="232" name="Panel 232"/>
+          <p:cNvSpPr/>
+          <p:nvPr/>
+        </p:nvSpPr>
+        <p:spPr>
+          <a:xfrm>
+            <a:off x="7435000" y="1715000"/>
+            <a:ext cx="1150000" cy="2445000"/>
+          </a:xfrm>
+          <a:prstGeom prst="roundRect">
+            <a:avLst/>
+          </a:prstGeom>
+          <a:solidFill>
+            <a:srgbClr val="FFFFFF"/>
+          </a:solidFill>
+          <a:ln>
+            <a:noFill/>
+          </a:ln>
+        </p:spPr>
+      </p:sp>
+      <p:pic>
+        <p:nvPicPr>
+          <p:cNvPr id="32" name="Wallet"/>
+          <p:cNvPicPr>
+            <a:picLocks noChangeAspect="1"/>
+          </p:cNvPicPr>
+          <p:nvPr/>
+        </p:nvPicPr>
+        <p:blipFill>
+          <a:blip r:embed="rId3"/>
+          <a:stretch>
+            <a:fillRect/>
+          </a:stretch>
+        </p:blipFill>
+        <p:spPr>
+          <a:xfrm>
+            <a:off x="7480000" y="1760000"/>
+            <a:ext cx="1060000" cy="2355000"/>
+          </a:xfrm>
+          <a:prstGeom prst="roundRect">
+            <a:avLst/>
+          </a:prstGeom>
+          <a:ln w="12700">
+            <a:solidFill>
+              <a:srgbClr val="E5E7EB"/>
+            </a:solidFill>
+          </a:ln>
+        </p:spPr>
+      </p:pic>
+      <p:sp>
+        <p:nvSpPr>
+          <p:cNvPr id="132" name="Text 132"/>
+          <p:cNvSpPr txBox="1"/>
+          <p:nvPr/>
+        </p:nvSpPr>
+        <p:spPr>
+          <a:xfrm>
+            <a:off x="7480000" y="4205000"/>
+            <a:ext cx="1060000" cy="240000"/>
+          </a:xfrm>
+          <a:prstGeom prst="rect">
+            <a:avLst/>
+          </a:prstGeom>
+          <a:noFill/>
+        </p:spPr>
+        <p:txBody>
+          <a:bodyPr wrap="square"/>
+          <a:lstStyle/>
+          <a:p>
+            <a:pPr>
+              <a:buNone/>
+            </a:pPr>
+            <a:r>
+              <a:rPr lang="en-US" sz="950">
+                <a:solidFill>
+                  <a:srgbClr val="4B5563"/>
+                </a:solidFill>
+              </a:rPr>
+              <a:t>Wallet</a:t>
             </a:r>
           </a:p>
         </p:txBody>
@@ -2449,7 +3554,7 @@
                   <a:srgbClr val="172033"/>
                 </a:solidFill>
               </a:rPr>
-              <a:t>Supports broad task categories instead of one narrow service vertical</a:t>
+              <a:t>Supports broad task and service categories instead of one narrow vertical</a:t>
             </a:r>
           </a:p>
           <a:p>

</xml_diff>

<commit_message>
Add on-ramp roadmap to pitch deck
</commit_message>
<xml_diff>
--- a/docs/bountix-pitch-deck.pptx
+++ b/docs/bountix-pitch-deck.pptx
@@ -549,6 +549,19 @@
                   <a:srgbClr val="172033"/>
                 </a:solidFill>
               </a:rPr>
+              <a:t>Integrate fiat on-ramp and off-ramp partners for easier USDC access</a:t>
+            </a:r>
+          </a:p>
+          <a:p>
+            <a:pPr marL="285750" indent="-171450">
+              <a:buChar char="•"/>
+            </a:pPr>
+            <a:r>
+              <a:rPr lang="en-US" sz="2050">
+                <a:solidFill>
+                  <a:srgbClr val="172033"/>
+                </a:solidFill>
+              </a:rPr>
               <a:t>Improve mobile-first UX for field tasks and local services</a:t>
             </a:r>
           </a:p>
@@ -562,20 +575,7 @@
                   <a:srgbClr val="172033"/>
                 </a:solidFill>
               </a:rPr>
-              <a:t>Expand moderation, task categories, service discovery, and payout reporting</a:t>
-            </a:r>
-          </a:p>
-          <a:p>
-            <a:pPr marL="285750" indent="-171450">
-              <a:buChar char="•"/>
-            </a:pPr>
-            <a:r>
-              <a:rPr lang="en-US" sz="2050">
-                <a:solidFill>
-                  <a:srgbClr val="172033"/>
-                </a:solidFill>
-              </a:rPr>
-              <a:t>Harden compliance, security, and production operations</a:t>
+              <a:t>Expand moderation, service discovery, payout reporting, compliance, and security</a:t>
             </a:r>
           </a:p>
         </p:txBody>

</xml_diff>